<commit_message>
Fix invisible text in pipeline diagram boxes
</commit_message>
<xml_diff>
--- a/docs/presentation.pptx
+++ b/docs/presentation.pptx
@@ -4029,9 +4029,9 @@
           <a:solidFill>
             <a:srgbClr val="151820"/>
           </a:solidFill>
-          <a:ln w="8890">
+          <a:ln w="10160">
             <a:solidFill>
-              <a:srgbClr val="7A7F95"/>
+              <a:srgbClr val="2A2D3A"/>
             </a:solidFill>
             <a:prstDash val="solid"/>
           </a:ln>
@@ -4064,7 +4064,7 @@
             <a:r>
               <a:rPr lang="en-US" sz="1000" dirty="0">
                 <a:solidFill>
-                  <a:srgbClr val="151820"/>
+                  <a:srgbClr val="E8EAF0"/>
                 </a:solidFill>
                 <a:latin typeface="Calibri" pitchFamily="34" charset="0"/>
                 <a:ea typeface="Calibri" pitchFamily="34" charset="-122"/>
@@ -4081,7 +4081,7 @@
             <a:r>
               <a:rPr lang="en-US" sz="1000" dirty="0">
                 <a:solidFill>
-                  <a:srgbClr val="151820"/>
+                  <a:srgbClr val="E8EAF0"/>
                 </a:solidFill>
                 <a:latin typeface="Calibri" pitchFamily="34" charset="0"/>
                 <a:ea typeface="Calibri" pitchFamily="34" charset="-122"/>
@@ -4389,9 +4389,9 @@
           <a:solidFill>
             <a:srgbClr val="151820"/>
           </a:solidFill>
-          <a:ln w="8890">
+          <a:ln w="10160">
             <a:solidFill>
-              <a:srgbClr val="7A7F95"/>
+              <a:srgbClr val="2A2D3A"/>
             </a:solidFill>
             <a:prstDash val="solid"/>
           </a:ln>
@@ -4424,7 +4424,7 @@
             <a:r>
               <a:rPr lang="en-US" sz="1000" dirty="0">
                 <a:solidFill>
-                  <a:srgbClr val="151820"/>
+                  <a:srgbClr val="E8EAF0"/>
                 </a:solidFill>
                 <a:latin typeface="Calibri" pitchFamily="34" charset="0"/>
                 <a:ea typeface="Calibri" pitchFamily="34" charset="-122"/>
@@ -4441,7 +4441,7 @@
             <a:r>
               <a:rPr lang="en-US" sz="1000" dirty="0">
                 <a:solidFill>
-                  <a:srgbClr val="151820"/>
+                  <a:srgbClr val="E8EAF0"/>
                 </a:solidFill>
                 <a:latin typeface="Calibri" pitchFamily="34" charset="0"/>
                 <a:ea typeface="Calibri" pitchFamily="34" charset="-122"/>

</xml_diff>

<commit_message>
Simplify fragment shader explanation on Slide 3
</commit_message>
<xml_diff>
--- a/docs/presentation.pptx
+++ b/docs/presentation.pptx
@@ -5047,7 +5047,7 @@
                 <a:ea typeface="Calibri" pitchFamily="34" charset="-122"/>
                 <a:cs typeface="Calibri" pitchFamily="34" charset="-120"/>
               </a:rPr>
-              <a:t>Fragment Shader — Blinn-Phong Illumination</a:t>
+              <a:t>Fragment Shader — Paint Each Pixel</a:t>
             </a:r>
             <a:endParaRPr lang="en-US" sz="1200" dirty="0"/>
           </a:p>
@@ -5062,7 +5062,46 @@
         <p:spPr>
           <a:xfrm>
             <a:off x="4773168" y="2148840"/>
-            <a:ext cx="3931920" cy="2560320"/>
+            <a:ext cx="3931920" cy="256032"/>
+          </a:xfrm>
+          <a:prstGeom prst="rect">
+            <a:avLst/>
+          </a:prstGeom>
+          <a:noFill/>
+          <a:ln/>
+        </p:spPr>
+        <p:txBody>
+          <a:bodyPr wrap="square" rtlCol="0" anchor="ctr"/>
+          <a:lstStyle/>
+          <a:p>
+            <a:pPr indent="0" marL="0">
+              <a:buNone/>
+            </a:pPr>
+            <a:r>
+              <a:rPr lang="en-US" sz="1100" dirty="0">
+                <a:solidFill>
+                  <a:srgbClr val="E8EAF0"/>
+                </a:solidFill>
+                <a:latin typeface="Calibri" pitchFamily="34" charset="0"/>
+                <a:ea typeface="Calibri" pitchFamily="34" charset="-122"/>
+                <a:cs typeface="Calibri" pitchFamily="34" charset="-120"/>
+              </a:rPr>
+              <a:t>For every pixel on screen, calculate its final colour:</a:t>
+            </a:r>
+            <a:endParaRPr lang="en-US" sz="1100" dirty="0"/>
+          </a:p>
+        </p:txBody>
+      </p:sp>
+      <p:sp>
+        <p:nvSpPr>
+          <p:cNvPr id="34" name="Text 32"/>
+          <p:cNvSpPr/>
+          <p:nvPr/>
+        </p:nvSpPr>
+        <p:spPr>
+          <a:xfrm>
+            <a:off x="4773168" y="2450592"/>
+            <a:ext cx="3931920" cy="1691640"/>
           </a:xfrm>
           <a:prstGeom prst="rect">
             <a:avLst/>
@@ -5076,13 +5115,13 @@
           <a:p>
             <a:pPr marL="342900" indent="-342900">
               <a:spcAft>
-                <a:spcPts val="1200"/>
+                <a:spcPts val="1000"/>
               </a:spcAft>
               <a:buSzPct val="100000"/>
               <a:buChar char="•"/>
             </a:pPr>
             <a:r>
-              <a:rPr lang="en-US" sz="1100" dirty="0">
+              <a:rPr lang="en-US" sz="1050" dirty="0">
                 <a:solidFill>
                   <a:srgbClr val="E8EAF0"/>
                 </a:solidFill>
@@ -5090,20 +5129,20 @@
                 <a:ea typeface="Calibri" pitchFamily="34" charset="-122"/>
                 <a:cs typeface="Calibri" pitchFamily="34" charset="-120"/>
               </a:rPr>
-              <a:t>Ambient (0.15) + Diffuse max(N·L, 0) + Specular (N·H)³²</a:t>
-            </a:r>
-            <a:endParaRPr lang="en-US" sz="1100" dirty="0"/>
+              <a:t>Sample the texture — look up the colour at this UV coordinate</a:t>
+            </a:r>
+            <a:endParaRPr lang="en-US" sz="1050" dirty="0"/>
           </a:p>
           <a:p>
             <a:pPr marL="342900" indent="-342900">
               <a:spcAft>
-                <a:spcPts val="1200"/>
+                <a:spcPts val="1000"/>
               </a:spcAft>
               <a:buSzPct val="100000"/>
               <a:buChar char="•"/>
             </a:pPr>
             <a:r>
-              <a:rPr lang="en-US" sz="1100" dirty="0">
+              <a:rPr lang="en-US" sz="1050" dirty="0">
                 <a:solidFill>
                   <a:srgbClr val="E8EAF0"/>
                 </a:solidFill>
@@ -5111,20 +5150,20 @@
                 <a:ea typeface="Calibri" pitchFamily="34" charset="-122"/>
                 <a:cs typeface="Calibri" pitchFamily="34" charset="-120"/>
               </a:rPr>
-              <a:t>Albedo texture sampled via mesh UV coordinates (stb_image)</a:t>
-            </a:r>
-            <a:endParaRPr lang="en-US" sz="1100" dirty="0"/>
+              <a:t>Calculate lighting — Ambient (always on) + Diffuse (angle to sun) + Specular (shiny reflection)</a:t>
+            </a:r>
+            <a:endParaRPr lang="en-US" sz="1050" dirty="0"/>
           </a:p>
           <a:p>
             <a:pPr marL="342900" indent="-342900">
               <a:spcAft>
-                <a:spcPts val="1200"/>
+                <a:spcPts val="1000"/>
               </a:spcAft>
               <a:buSzPct val="100000"/>
               <a:buChar char="•"/>
             </a:pPr>
             <a:r>
-              <a:rPr lang="en-US" sz="1100" dirty="0">
+              <a:rPr lang="en-US" sz="1050" dirty="0">
                 <a:solidFill>
                   <a:srgbClr val="E8EAF0"/>
                 </a:solidFill>
@@ -5132,20 +5171,20 @@
                 <a:ea typeface="Calibri" pitchFamily="34" charset="-122"/>
                 <a:cs typeface="Calibri" pitchFamily="34" charset="-120"/>
               </a:rPr>
-              <a:t>Normals transformed using the inverse-transpose of the skin matrix</a:t>
-            </a:r>
-            <a:endParaRPr lang="en-US" sz="1100" dirty="0"/>
+              <a:t>Combine texture × lighting to get final pixel colour</a:t>
+            </a:r>
+            <a:endParaRPr lang="en-US" sz="1050" dirty="0"/>
           </a:p>
           <a:p>
             <a:pPr marL="342900" indent="-342900">
               <a:spcAft>
-                <a:spcPts val="1200"/>
+                <a:spcPts val="1000"/>
               </a:spcAft>
               <a:buSzPct val="100000"/>
               <a:buChar char="•"/>
             </a:pPr>
             <a:r>
-              <a:rPr lang="en-US" sz="1100" dirty="0">
+              <a:rPr lang="en-US" sz="1050" dirty="0">
                 <a:solidFill>
                   <a:srgbClr val="E8EAF0"/>
                 </a:solidFill>
@@ -5153,15 +5192,54 @@
                 <a:ea typeface="Calibri" pitchFamily="34" charset="-122"/>
                 <a:cs typeface="Calibri" pitchFamily="34" charset="-120"/>
               </a:rPr>
-              <a:t>Grey fallback colour for models without an albedo texture</a:t>
-            </a:r>
-            <a:endParaRPr lang="en-US" sz="1100" dirty="0"/>
-          </a:p>
-        </p:txBody>
-      </p:sp>
-      <p:sp>
-        <p:nvSpPr>
-          <p:cNvPr id="34" name="Text 32"/>
+              <a:t>Normals are transformed using inverse-transpose to stay correct through bone deformation</a:t>
+            </a:r>
+            <a:endParaRPr lang="en-US" sz="1050" dirty="0"/>
+          </a:p>
+        </p:txBody>
+      </p:sp>
+      <p:sp>
+        <p:nvSpPr>
+          <p:cNvPr id="35" name="Text 33"/>
+          <p:cNvSpPr/>
+          <p:nvPr/>
+        </p:nvSpPr>
+        <p:spPr>
+          <a:xfrm>
+            <a:off x="4773168" y="4325112"/>
+            <a:ext cx="3931920" cy="457200"/>
+          </a:xfrm>
+          <a:prstGeom prst="rect">
+            <a:avLst/>
+          </a:prstGeom>
+          <a:noFill/>
+          <a:ln/>
+        </p:spPr>
+        <p:txBody>
+          <a:bodyPr wrap="square" rtlCol="0" anchor="ctr"/>
+          <a:lstStyle/>
+          <a:p>
+            <a:pPr indent="0" marL="0">
+              <a:buNone/>
+            </a:pPr>
+            <a:r>
+              <a:rPr lang="en-US" sz="1000" dirty="0">
+                <a:solidFill>
+                  <a:srgbClr val="7A7F95"/>
+                </a:solidFill>
+                <a:latin typeface="Calibri" pitchFamily="34" charset="0"/>
+                <a:ea typeface="Calibri" pitchFamily="34" charset="-122"/>
+                <a:cs typeface="Calibri" pitchFamily="34" charset="-120"/>
+              </a:rPr>
+              <a:t>Result: realistic shading with texture colours and shadows.</a:t>
+            </a:r>
+            <a:endParaRPr lang="en-US" sz="1000" dirty="0"/>
+          </a:p>
+        </p:txBody>
+      </p:sp>
+      <p:sp>
+        <p:nvSpPr>
+          <p:cNvPr id="36" name="Text 34"/>
           <p:cNvSpPr/>
           <p:nvPr/>
         </p:nvSpPr>

</xml_diff>